<commit_message>
docs(pitch-decks): fix NYCA Partners with verified facts only
- Removed unverifiable 'Former OCC Comptroller as advisor' claim
- Fixed Hans Morris title: ex-Visa President, ex-Citi CFO (was incorrectly 'ex-OCC')
- Fixed AUM: ~ (was overstated as +, LinkedIn says 'just under  billion')
- Replaced non-existent 'David Bielan' with verified team: Ravi Mohan (COO), Stephanie Khoo (Partner)
- Updated whyAlign to reference verified portfolio (Socure, Alloy, Figure) with specific roles
- Updated hookSlide and keyAngle with verifiable positioning
- Regenerated INVESTOR-EMAILS.md (483 emails) and all 120 PPTX decks
- Fixed OUTREACH-CONTACTS.md with correct partner names and titles
</commit_message>
<xml_diff>
--- a/docs/pitch-decks/investor-100/pptx/040-nyca.pptx
+++ b/docs/pitch-decks/investor-100/pptx/040-nyca.pptx
@@ -1967,7 +1967,7 @@
                   <a:srgbClr val="8B8FA3"/>
                 </a:solidFill>
               </a:rPr>
-              <a:t>Venture Capital · New York, NY · Series A to B · $1B+ AUM</a:t>
+              <a:t>Venture Capital · New York, NY · Series A to B · ~$1B AUM</a:t>
             </a:r>
             <a:endParaRPr lang="en-US" sz="1200" dirty="0"/>
           </a:p>
@@ -2215,7 +2215,7 @@
                   <a:srgbClr val="8B8FA3"/>
                 </a:solidFill>
               </a:rPr>
-              <a:t>Personalized for Nyca Partners — Regulatory expertise meets AI governance mandate</a:t>
+              <a:t>Personalized for Nyca Partners — AI governance infrastructure for regulated financial services</a:t>
             </a:r>
             <a:endParaRPr lang="en-US" sz="1400" dirty="0"/>
           </a:p>
@@ -2770,7 +2770,7 @@
                   <a:srgbClr val="8B8FA3"/>
                 </a:solidFill>
               </a:rPr>
-              <a:t>Financial services technology. Co-founded by Hans Morris (ex-Visa, ex-Citigroup). Former OCC Comptroller as advisor. Deep regulatory expertise and bank network.</a:t>
+              <a:t>Financial services technology. Founded by Hans Morris (ex-Visa President, ex-Citi CFO). 100+ senior financial services LP advisors. Deep regulatory expertise and bank network.</a:t>
             </a:r>
             <a:endParaRPr lang="en-US" sz="1200" dirty="0"/>
           </a:p>
@@ -2867,7 +2867,7 @@
                   <a:srgbClr val="8B8FA3"/>
                 </a:solidFill>
               </a:rPr>
-              <a:t>Nyca's regulatory network (including former OCC Comptroller) understands mandates better than any VC. DORA, EU AI Act, and Basel III create mandatory AI governance demand.</a:t>
+              <a:t>Nyca bridges Wall Street and Silicon Valley — Hans Morris built the firm specifically to connect fintech to regulated financial institutions. DORA, EU AI Act, and Basel III create mandatory AI governance demand, and Nyca's 100+ senior financial services advisors understand this better than any VC.</a:t>
             </a:r>
             <a:endParaRPr lang="en-US" sz="1100" dirty="0"/>
           </a:p>
@@ -3058,7 +3058,7 @@
                   <a:srgbClr val="8B8FA3"/>
                 </a:solidFill>
               </a:rPr>
-              <a:t>Nyca's regulatory advisory network has unmatched insight. They know AI governance will be mandatory. Datacendia is built for the regulations Nyca's network enforces.</a:t>
+              <a:t>Nyca backed Socure (identity verification), Alloy (compliance automation), and Figure (blockchain lending) — all face AI governance requirements. Datacendia is the decision evidence layer their portfolio companies and their bank customers both need.</a:t>
             </a:r>
             <a:endParaRPr lang="en-US" sz="1100" dirty="0"/>
           </a:p>
@@ -4194,7 +4194,7 @@
                   <a:srgbClr val="FFFFFF"/>
                 </a:solidFill>
               </a:rPr>
-              <a:t>Regulatory expertise meets AI governance mandate</a:t>
+              <a:t>AI governance infrastructure for regulated financial services</a:t>
             </a:r>
             <a:endParaRPr lang="en-US" sz="1400" dirty="0"/>
           </a:p>

</xml_diff>